<commit_message>
chore: daily content 2026-09-13
</commit_message>
<xml_diff>
--- a/data/2026-09-13/slides.pptx
+++ b/data/2026-09-13/slides.pptx
@@ -513,7 +513,7 @@
           </a:p>
           <a:p>
             <a:r>
-              <a:t>대본: JAK 억제제 오늘 나온 최신 연구를 정리했습니다</a:t>
+              <a:t>대본: 90% 이 숫자, 탈모 연구가 새로 내놨습니다</a:t>
             </a:r>
           </a:p>
           <a:p>
@@ -593,7 +593,7 @@
           </a:p>
           <a:p>
             <a:r>
-              <a:t>대본: 《Journal of the American Academy of Dermatology》 - Pediatric Alopecia Areata and JAK Inhibitors: Bridging the Gap Between Evidence and Practice</a:t>
+              <a:t>대본: 《Journal of the American Academy of Dermatology》 - Dose optimization of deuruxolitinib in adults with alopecia areata: A phase 2 randomized trial</a:t>
             </a:r>
           </a:p>
           <a:p>
@@ -673,7 +673,7 @@
           </a:p>
           <a:p>
             <a:r>
-              <a:t>대본: Alopecia areata (AA) is a chronic immune-mediated disorder characterized by nonscarring hair loss that frequently begins in childhood and is associated with substantial psychosocial burden.</a:t>
+              <a:t>대본: Objective: To evaluate the efficacy and safety of the Janus kinase 1/2 inhibitor deuruxolitinib dosed 8 mg twice daily (BID) or 16 mg once daily (QD) in adults with severe AA.</a:t>
             </a:r>
           </a:p>
           <a:p>
@@ -753,7 +753,7 @@
           </a:p>
           <a:p>
             <a:r>
-              <a:t>대본: Therapeutic options for pediatric AA remain limited, particularly for patients with extensive or treatment-resistant disease.</a:t>
+              <a:t>대본: Methods: In this phase 2 study (NCT03811912), patients were randomized to deuruxolitinib 8 mg BID or 16 mg QD.</a:t>
             </a:r>
           </a:p>
           <a:p>
@@ -3997,7 +3997,7 @@
                 </a:solidFill>
                 <a:latin typeface="Arial"/>
               </a:rPr>
-              <a:t>JAK 억제제</a:t>
+              <a:t>90%</a:t>
             </a:r>
           </a:p>
         </p:txBody>
@@ -4032,7 +4032,7 @@
                 </a:solidFill>
                 <a:latin typeface="Arial"/>
               </a:rPr>
-              <a:t>오늘 나온 최신 연구를 정리했습니다</a:t>
+              <a:t>이 숫자, 탈모 연구가 새로 내놨습니다</a:t>
             </a:r>
           </a:p>
         </p:txBody>
@@ -4152,7 +4152,7 @@
                 </a:solidFill>
                 <a:latin typeface="Arial"/>
               </a:rPr>
-              <a:t>Pediatric Alopecia Areata and JAK Inhibitors: Bridging the Gap Between Evidence and Practice</a:t>
+              <a:t>Dose optimization of deuruxolitinib in adults with alopecia areata: A phase 2 randomized trial</a:t>
             </a:r>
           </a:p>
         </p:txBody>
@@ -4316,7 +4316,7 @@
                 </a:solidFill>
                 <a:latin typeface="Arial"/>
               </a:rPr>
-              <a:t>Alopecia areata (AA) is a chronic immune-mediated disorder characterized by nonscarring hair loss that frequently begins in childhood and is associated with substantial psychosocial burden.</a:t>
+              <a:t>Objective: To evaluate the efficacy and safety of the Janus kinase 1/2 inhibitor deuruxolitinib dosed 8 mg twice daily (BID) or 16 mg once daily (QD) in adults with severe AA.</a:t>
             </a:r>
           </a:p>
         </p:txBody>
@@ -4445,7 +4445,7 @@
                 </a:solidFill>
                 <a:latin typeface="Arial"/>
               </a:rPr>
-              <a:t>Therapeutic options for pediatric AA remain limited, particularly for patients with extensive or treatment-resistant disease.</a:t>
+              <a:t>Methods: In this phase 2 study (NCT03811912), patients were randomized to deuruxolitinib 8 mg BID or 16 mg QD.</a:t>
             </a:r>
           </a:p>
         </p:txBody>
@@ -4732,9 +4732,9 @@
                 <a:latin typeface="Arial"/>
               </a:rPr>
               <a:t>[출처]
-논문: Pediatric Alopecia Areata and JAK Inhibitors: Bridging the Gap Between Evidence and Practice
+논문: Dose optimization of deuruxolitinib in adults with alopecia areata: A phase 2 randomized trial
 게재: Journal of the American Academy of Dermatology
-원문: https://pubmed.ncbi.nlm.nih.gov/42727783/
+원문: https://pubmed.ncbi.nlm.nih.gov/42727780/
 [이미지 출처]
 - Male pattern baldness.jpg / Originally uploaded by Lkinkade (Transferred by XenonX3) / CC BY-SA 2.5
   https://commons.wikimedia.org/wiki/File:Male_pattern_baldness.jpg

</xml_diff>